<commit_message>
fix: skills section reduction
</commit_message>
<xml_diff>
--- a/Templates/Template_CV_format_DVT.pptx
+++ b/Templates/Template_CV_format_DVT.pptx
@@ -10451,7 +10451,7 @@
         <p:fade/>
       </p:transition>
     </mc:Choice>
-    <mc:Fallback xmlns="" xmlns:mv="urn:schemas-microsoft-com:mac:vml" xmlns:c="http://schemas.openxmlformats.org/drawingml/2006/chart" xmlns:dgm="http://schemas.openxmlformats.org/drawingml/2006/diagram" xmlns:o="urn:schemas-microsoft-com:office:office" xmlns:v="urn:schemas-microsoft-com:vml" xmlns:pvml="urn:schemas-microsoft-com:office:powerpoint" xmlns:com="http://schemas.openxmlformats.org/drawingml/2006/compatibility" xmlns:p15="http://schemas.microsoft.com/office/powerpoint/2012/main" xmlns:ahyp="http://schemas.microsoft.com/office/drawing/2018/hyperlinkcolor">
+    <mc:Fallback xmlns:ahyp="http://schemas.microsoft.com/office/drawing/2018/hyperlinkcolor" xmlns:p15="http://schemas.microsoft.com/office/powerpoint/2012/main" xmlns:com="http://schemas.openxmlformats.org/drawingml/2006/compatibility" xmlns:pvml="urn:schemas-microsoft-com:office:powerpoint" xmlns:v="urn:schemas-microsoft-com:vml" xmlns:o="urn:schemas-microsoft-com:office:office" xmlns:dgm="http://schemas.openxmlformats.org/drawingml/2006/diagram" xmlns:c="http://schemas.openxmlformats.org/drawingml/2006/chart" xmlns:mv="urn:schemas-microsoft-com:mac:vml" xmlns="">
       <p:transition spd="med">
         <p:fade/>
       </p:transition>
@@ -17865,136 +17865,6 @@
           </a:prstGeom>
         </p:spPr>
       </p:pic>
-      <p:pic>
-        <p:nvPicPr>
-          <p:cNvPr id="9" name="Picture 8" descr="BNP Paribas APM | Secure Bank Transfers via BNP Paribas (Poland) | Nuvei">
-            <a:extLst>
-              <a:ext uri="{FF2B5EF4-FFF2-40B4-BE49-F238E27FC236}">
-                <a16:creationId xmlns:a16="http://schemas.microsoft.com/office/drawing/2014/main" id="{31D844EB-1213-51E4-168A-C35FE5FAC789}"/>
-              </a:ext>
-            </a:extLst>
-          </p:cNvPr>
-          <p:cNvPicPr>
-            <a:picLocks noChangeAspect="1"/>
-          </p:cNvPicPr>
-          <p:nvPr/>
-        </p:nvPicPr>
-        <p:blipFill>
-          <a:blip r:embed="rId4"/>
-          <a:srcRect l="8215" t="18070" r="9473" b="17869"/>
-          <a:stretch>
-            <a:fillRect/>
-          </a:stretch>
-        </p:blipFill>
-        <p:spPr>
-          <a:xfrm>
-            <a:off x="5397451" y="1131194"/>
-            <a:ext cx="956167" cy="464925"/>
-          </a:xfrm>
-          <a:prstGeom prst="rect">
-            <a:avLst/>
-          </a:prstGeom>
-        </p:spPr>
-      </p:pic>
-      <p:pic>
-        <p:nvPicPr>
-          <p:cNvPr id="11" name="Google Shape;899;p91">
-            <a:extLst>
-              <a:ext uri="{FF2B5EF4-FFF2-40B4-BE49-F238E27FC236}">
-                <a16:creationId xmlns:a16="http://schemas.microsoft.com/office/drawing/2014/main" id="{5C09DBA2-1B50-1880-19A2-A132262DC376}"/>
-              </a:ext>
-            </a:extLst>
-          </p:cNvPr>
-          <p:cNvPicPr preferRelativeResize="0"/>
-          <p:nvPr/>
-        </p:nvPicPr>
-        <p:blipFill rotWithShape="1">
-          <a:blip r:embed="rId5" cstate="screen">
-            <a:alphaModFix/>
-            <a:extLst>
-              <a:ext uri="{28A0092B-C50C-407E-A947-70E740481C1C}">
-                <a14:useLocalDpi xmlns:a14="http://schemas.microsoft.com/office/drawing/2010/main"/>
-              </a:ext>
-            </a:extLst>
-          </a:blip>
-          <a:srcRect/>
-          <a:stretch/>
-        </p:blipFill>
-        <p:spPr>
-          <a:xfrm>
-            <a:off x="3982618" y="1249398"/>
-            <a:ext cx="1098496" cy="247462"/>
-          </a:xfrm>
-          <a:prstGeom prst="rect">
-            <a:avLst/>
-          </a:prstGeom>
-          <a:noFill/>
-          <a:ln>
-            <a:noFill/>
-          </a:ln>
-        </p:spPr>
-      </p:pic>
-      <p:pic>
-        <p:nvPicPr>
-          <p:cNvPr id="13" name="Picture 12" descr="BMCI Groupe BNP Paribas">
-            <a:extLst>
-              <a:ext uri="{FF2B5EF4-FFF2-40B4-BE49-F238E27FC236}">
-                <a16:creationId xmlns:a16="http://schemas.microsoft.com/office/drawing/2014/main" id="{3AC2A943-C18C-CDED-2A1D-86F5378644D2}"/>
-              </a:ext>
-            </a:extLst>
-          </p:cNvPr>
-          <p:cNvPicPr>
-            <a:picLocks noChangeAspect="1"/>
-          </p:cNvPicPr>
-          <p:nvPr/>
-        </p:nvPicPr>
-        <p:blipFill>
-          <a:blip r:embed="rId6"/>
-          <a:srcRect t="24731" b="19549"/>
-          <a:stretch>
-            <a:fillRect/>
-          </a:stretch>
-        </p:blipFill>
-        <p:spPr>
-          <a:xfrm>
-            <a:off x="6523865" y="1065467"/>
-            <a:ext cx="1108647" cy="617743"/>
-          </a:xfrm>
-          <a:prstGeom prst="rect">
-            <a:avLst/>
-          </a:prstGeom>
-        </p:spPr>
-      </p:pic>
-      <p:pic>
-        <p:nvPicPr>
-          <p:cNvPr id="15" name="Picture 14" descr="UBCI | Nous connaitre">
-            <a:extLst>
-              <a:ext uri="{FF2B5EF4-FFF2-40B4-BE49-F238E27FC236}">
-                <a16:creationId xmlns:a16="http://schemas.microsoft.com/office/drawing/2014/main" id="{BE5555BB-11F5-F0E8-34B2-7C2C920BB064}"/>
-              </a:ext>
-            </a:extLst>
-          </p:cNvPr>
-          <p:cNvPicPr>
-            <a:picLocks noChangeAspect="1"/>
-          </p:cNvPicPr>
-          <p:nvPr/>
-        </p:nvPicPr>
-        <p:blipFill>
-          <a:blip r:embed="rId7"/>
-          <a:stretch>
-            <a:fillRect/>
-          </a:stretch>
-        </p:blipFill>
-        <p:spPr>
-          <a:xfrm>
-            <a:off x="7900400" y="1249398"/>
-            <a:ext cx="929493" cy="279603"/>
-          </a:xfrm>
-          <a:prstGeom prst="rect">
-            <a:avLst/>
-          </a:prstGeom>
-        </p:spPr>
-      </p:pic>
     </p:spTree>
     <p:extLst>
       <p:ext uri="{BB962C8B-B14F-4D97-AF65-F5344CB8AC3E}">
@@ -19087,136 +18957,6 @@
             <a:ext cx="1198106" cy="1051800"/>
           </a:xfrm>
           <a:prstGeom prst="ellipse">
-            <a:avLst/>
-          </a:prstGeom>
-        </p:spPr>
-      </p:pic>
-      <p:pic>
-        <p:nvPicPr>
-          <p:cNvPr id="18" name="Picture 17" descr="BNP Paribas APM | Secure Bank Transfers via BNP Paribas (Poland) | Nuvei">
-            <a:extLst>
-              <a:ext uri="{FF2B5EF4-FFF2-40B4-BE49-F238E27FC236}">
-                <a16:creationId xmlns:a16="http://schemas.microsoft.com/office/drawing/2014/main" id="{CA14C6B4-5380-4FE3-15CA-75490A2776B2}"/>
-              </a:ext>
-            </a:extLst>
-          </p:cNvPr>
-          <p:cNvPicPr>
-            <a:picLocks noChangeAspect="1"/>
-          </p:cNvPicPr>
-          <p:nvPr/>
-        </p:nvPicPr>
-        <p:blipFill>
-          <a:blip r:embed="rId3"/>
-          <a:srcRect l="8215" t="18070" r="9473" b="17869"/>
-          <a:stretch>
-            <a:fillRect/>
-          </a:stretch>
-        </p:blipFill>
-        <p:spPr>
-          <a:xfrm>
-            <a:off x="5397451" y="1131194"/>
-            <a:ext cx="956167" cy="464925"/>
-          </a:xfrm>
-          <a:prstGeom prst="rect">
-            <a:avLst/>
-          </a:prstGeom>
-        </p:spPr>
-      </p:pic>
-      <p:pic>
-        <p:nvPicPr>
-          <p:cNvPr id="20" name="Google Shape;899;p91">
-            <a:extLst>
-              <a:ext uri="{FF2B5EF4-FFF2-40B4-BE49-F238E27FC236}">
-                <a16:creationId xmlns:a16="http://schemas.microsoft.com/office/drawing/2014/main" id="{60E9E407-A7A1-FAEC-0D77-C01E7089B582}"/>
-              </a:ext>
-            </a:extLst>
-          </p:cNvPr>
-          <p:cNvPicPr preferRelativeResize="0"/>
-          <p:nvPr/>
-        </p:nvPicPr>
-        <p:blipFill rotWithShape="1">
-          <a:blip r:embed="rId4" cstate="screen">
-            <a:alphaModFix/>
-            <a:extLst>
-              <a:ext uri="{28A0092B-C50C-407E-A947-70E740481C1C}">
-                <a14:useLocalDpi xmlns:a14="http://schemas.microsoft.com/office/drawing/2010/main"/>
-              </a:ext>
-            </a:extLst>
-          </a:blip>
-          <a:srcRect/>
-          <a:stretch/>
-        </p:blipFill>
-        <p:spPr>
-          <a:xfrm>
-            <a:off x="3982618" y="1249398"/>
-            <a:ext cx="1098496" cy="247462"/>
-          </a:xfrm>
-          <a:prstGeom prst="rect">
-            <a:avLst/>
-          </a:prstGeom>
-          <a:noFill/>
-          <a:ln>
-            <a:noFill/>
-          </a:ln>
-        </p:spPr>
-      </p:pic>
-      <p:pic>
-        <p:nvPicPr>
-          <p:cNvPr id="22" name="Picture 21" descr="BMCI Groupe BNP Paribas">
-            <a:extLst>
-              <a:ext uri="{FF2B5EF4-FFF2-40B4-BE49-F238E27FC236}">
-                <a16:creationId xmlns:a16="http://schemas.microsoft.com/office/drawing/2014/main" id="{758FFA84-6019-AA42-10EB-BEA554BEF4C2}"/>
-              </a:ext>
-            </a:extLst>
-          </p:cNvPr>
-          <p:cNvPicPr>
-            <a:picLocks noChangeAspect="1"/>
-          </p:cNvPicPr>
-          <p:nvPr/>
-        </p:nvPicPr>
-        <p:blipFill>
-          <a:blip r:embed="rId5"/>
-          <a:srcRect t="24731" b="19549"/>
-          <a:stretch>
-            <a:fillRect/>
-          </a:stretch>
-        </p:blipFill>
-        <p:spPr>
-          <a:xfrm>
-            <a:off x="6523865" y="1065467"/>
-            <a:ext cx="1108647" cy="617743"/>
-          </a:xfrm>
-          <a:prstGeom prst="rect">
-            <a:avLst/>
-          </a:prstGeom>
-        </p:spPr>
-      </p:pic>
-      <p:pic>
-        <p:nvPicPr>
-          <p:cNvPr id="24" name="Picture 23" descr="UBCI | Nous connaitre">
-            <a:extLst>
-              <a:ext uri="{FF2B5EF4-FFF2-40B4-BE49-F238E27FC236}">
-                <a16:creationId xmlns:a16="http://schemas.microsoft.com/office/drawing/2014/main" id="{E720C7A7-E968-70D6-0015-59606F9F017E}"/>
-              </a:ext>
-            </a:extLst>
-          </p:cNvPr>
-          <p:cNvPicPr>
-            <a:picLocks noChangeAspect="1"/>
-          </p:cNvPicPr>
-          <p:nvPr/>
-        </p:nvPicPr>
-        <p:blipFill>
-          <a:blip r:embed="rId6"/>
-          <a:stretch>
-            <a:fillRect/>
-          </a:stretch>
-        </p:blipFill>
-        <p:spPr>
-          <a:xfrm>
-            <a:off x="7900400" y="1249398"/>
-            <a:ext cx="929493" cy="279603"/>
-          </a:xfrm>
-          <a:prstGeom prst="rect">
             <a:avLst/>
           </a:prstGeom>
         </p:spPr>

</xml_diff>

<commit_message>
fix: delete candidate from any step
</commit_message>
<xml_diff>
--- a/Templates/Template_CV_format_DVT.pptx
+++ b/Templates/Template_CV_format_DVT.pptx
@@ -16861,7 +16861,7 @@
         </p:nvSpPr>
         <p:spPr>
           <a:xfrm>
-            <a:off x="131077" y="2140702"/>
+            <a:off x="131077" y="2203089"/>
             <a:ext cx="7909539" cy="151117"/>
           </a:xfrm>
           <a:prstGeom prst="rect">
@@ -17010,7 +17010,7 @@
         </p:nvSpPr>
         <p:spPr>
           <a:xfrm>
-            <a:off x="131076" y="2327844"/>
+            <a:off x="131077" y="2364219"/>
             <a:ext cx="3978000" cy="186118"/>
           </a:xfrm>
           <a:prstGeom prst="rect">
@@ -17054,8 +17054,8 @@
         </p:nvSpPr>
         <p:spPr>
           <a:xfrm>
-            <a:off x="77051" y="1435442"/>
-            <a:ext cx="4153168" cy="1571595"/>
+            <a:off x="43493" y="1356171"/>
+            <a:ext cx="4153168" cy="1390555"/>
           </a:xfrm>
           <a:prstGeom prst="rect">
             <a:avLst/>
@@ -17425,7 +17425,7 @@
         </p:nvSpPr>
         <p:spPr>
           <a:xfrm>
-            <a:off x="134011" y="1188802"/>
+            <a:off x="131077" y="1167879"/>
             <a:ext cx="3851466" cy="217382"/>
           </a:xfrm>
           <a:prstGeom prst="rect">

</xml_diff>